<commit_message>
Actualiza el equipo: Cintia Venecia, Mariela Caminos, Cristina Soto, Lourdes Gimenez Bravo
Reemplaza los nombres viejos en la app, el README y el pitch deck.

Co-Authored-By: Claude Opus 4.8 <noreply@anthropic.com>
</commit_message>
<xml_diff>
--- a/presentacion/Minga-Pitch.pptx
+++ b/presentacion/Minga-Pitch.pptx
@@ -1839,7 +1839,7 @@
                 <a:ea typeface="Calibri" pitchFamily="34" charset="-122"/>
                 <a:cs typeface="Calibri" pitchFamily="34" charset="-120"/>
               </a:rPr>
-              <a:t>Cintia Venecia · Ivon Fernández · Mariela Caminos</a:t>
+              <a:t>Cintia Venecia · Mariela Caminos · Cristina Soto · Lourdes Gimenez Bravo</a:t>
             </a:r>
             <a:endParaRPr lang="en-US" sz="1400" dirty="0"/>
           </a:p>
@@ -7403,7 +7403,7 @@
                 <a:ea typeface="Calibri" pitchFamily="34" charset="-122"/>
                 <a:cs typeface="Calibri" pitchFamily="34" charset="-120"/>
               </a:rPr>
-              <a:t>Cintia Venecia · Ivon Fernández · Mariela Caminos</a:t>
+              <a:t>Cintia Venecia · Mariela Caminos · Cristina Soto · Lourdes Gimenez Bravo</a:t>
             </a:r>
             <a:endParaRPr lang="en-US" sz="1800" dirty="0"/>
           </a:p>

</xml_diff>